<commit_message>
final: light deck theme, links with showcase URL
- Deck: light theme on every slide (white background, dark text, one green accent; no dark header band;
  "planned" boxes grey and dashed). Content and numbers unchanged. Rebuilt with the team name and the new
  video link (https://youtu.be/UUdfN2WERf4).
- submission/links.txt: team, registered project title, prototype status, track, live app, GitHub, model,
  Worker Studio showcase and the demo video.
- Video: video/make_demo_cut.py cuts the raw recording to 1:58 (dead time removed, speech not sped up,
  English subtitles burned in for the Bangla app clips, results caption); video/subtitles_en.srt re-timed to
  the final cut from video/narration_transcript.json (local transcript, mishearings corrected).
- README: demo video link. .gitignore: deck/preview/, video/preview/, submission/final/.

Co-Authored-By: Claude Opus 5.5 <noreply@anthropic.com>
</commit_message>
<xml_diff>
--- a/deck/Kom_Bish_deck.pptx
+++ b/deck/Kom_Bish_deck.pptx
@@ -3998,6 +3998,14 @@
 <file path=ppt/slides/slide1.xml><?xml version="1.0" encoding="utf-8"?>
 <p:sld xmlns:a="http://schemas.openxmlformats.org/drawingml/2006/main" xmlns:p="http://schemas.openxmlformats.org/presentationml/2006/main" xmlns:r="http://schemas.openxmlformats.org/officeDocument/2006/relationships">
   <p:cSld>
+    <p:bg>
+      <p:bgPr>
+        <a:solidFill>
+          <a:srgbClr val="FFFFFF"/>
+        </a:solidFill>
+        <a:effectLst/>
+      </p:bgPr>
+    </p:bg>
     <p:spTree>
       <p:nvGrpSpPr>
         <p:cNvPr id="1" name=""/>
@@ -4237,6 +4245,21 @@
                 </a:solidFill>
               </a:rPr>
               <a:t>Model: https://huggingface.co/Raiyan465/kom-bish-rice-leaf</a:t>
+            </a:r>
+          </a:p>
+          <a:p>
+            <a:pPr>
+              <a:spcAft>
+                <a:spcPts val="300"/>
+              </a:spcAft>
+            </a:pPr>
+            <a:r>
+              <a:rPr sz="1500" b="0">
+                <a:solidFill>
+                  <a:srgbClr val="1B1B1B"/>
+                </a:solidFill>
+              </a:rPr>
+              <a:t>Video: https://youtu.be/UUdfN2WERf4</a:t>
             </a:r>
           </a:p>
         </p:txBody>
@@ -4357,6 +4380,14 @@
 <file path=ppt/slides/slide2.xml><?xml version="1.0" encoding="utf-8"?>
 <p:sld xmlns:a="http://schemas.openxmlformats.org/drawingml/2006/main" xmlns:p="http://schemas.openxmlformats.org/presentationml/2006/main" xmlns:r="http://schemas.openxmlformats.org/officeDocument/2006/relationships">
   <p:cSld>
+    <p:bg>
+      <p:bgPr>
+        <a:solidFill>
+          <a:srgbClr val="FFFFFF"/>
+        </a:solidFill>
+        <a:effectLst/>
+      </p:bgPr>
+    </p:bg>
     <p:spTree>
       <p:nvGrpSpPr>
         <p:cNvPr id="1" name=""/>
@@ -4933,6 +4964,14 @@
 <file path=ppt/slides/slide3.xml><?xml version="1.0" encoding="utf-8"?>
 <p:sld xmlns:a="http://schemas.openxmlformats.org/drawingml/2006/main" xmlns:p="http://schemas.openxmlformats.org/presentationml/2006/main" xmlns:r="http://schemas.openxmlformats.org/officeDocument/2006/relationships">
   <p:cSld>
+    <p:bg>
+      <p:bgPr>
+        <a:solidFill>
+          <a:srgbClr val="FFFFFF"/>
+        </a:solidFill>
+        <a:effectLst/>
+      </p:bgPr>
+    </p:bg>
     <p:spTree>
       <p:nvGrpSpPr>
         <p:cNvPr id="1" name=""/>
@@ -5376,6 +5415,14 @@
 <file path=ppt/slides/slide4.xml><?xml version="1.0" encoding="utf-8"?>
 <p:sld xmlns:a="http://schemas.openxmlformats.org/drawingml/2006/main" xmlns:p="http://schemas.openxmlformats.org/presentationml/2006/main" xmlns:r="http://schemas.openxmlformats.org/officeDocument/2006/relationships">
   <p:cSld>
+    <p:bg>
+      <p:bgPr>
+        <a:solidFill>
+          <a:srgbClr val="FFFFFF"/>
+        </a:solidFill>
+        <a:effectLst/>
+      </p:bgPr>
+    </p:bg>
     <p:spTree>
       <p:nvGrpSpPr>
         <p:cNvPr id="1" name=""/>
@@ -6088,6 +6135,14 @@
 <file path=ppt/slides/slide5.xml><?xml version="1.0" encoding="utf-8"?>
 <p:sld xmlns:a="http://schemas.openxmlformats.org/drawingml/2006/main" xmlns:p="http://schemas.openxmlformats.org/presentationml/2006/main" xmlns:r="http://schemas.openxmlformats.org/officeDocument/2006/relationships">
   <p:cSld>
+    <p:bg>
+      <p:bgPr>
+        <a:solidFill>
+          <a:srgbClr val="FFFFFF"/>
+        </a:solidFill>
+        <a:effectLst/>
+      </p:bgPr>
+    </p:bg>
     <p:spTree>
       <p:nvGrpSpPr>
         <p:cNvPr id="1" name=""/>
@@ -7276,7 +7331,7 @@
             <a:r>
               <a:rPr sz="1400" b="1">
                 <a:solidFill>
-                  <a:srgbClr val="E67E00"/>
+                  <a:srgbClr val="808080"/>
                 </a:solidFill>
               </a:rPr>
               <a:t>Planned, not built or not switched on</a:t>
@@ -7299,11 +7354,11 @@
             <a:avLst/>
           </a:prstGeom>
           <a:solidFill>
-            <a:srgbClr val="FFF3D6"/>
+            <a:srgbClr val="F5F5F5"/>
           </a:solidFill>
           <a:ln w="19050">
             <a:solidFill>
-              <a:srgbClr val="E67E00"/>
+              <a:srgbClr val="808080"/>
             </a:solidFill>
             <a:prstDash val="dash"/>
           </a:ln>
@@ -7364,11 +7419,11 @@
             <a:avLst/>
           </a:prstGeom>
           <a:solidFill>
-            <a:srgbClr val="FFF3D6"/>
+            <a:srgbClr val="F5F5F5"/>
           </a:solidFill>
           <a:ln w="19050">
             <a:solidFill>
-              <a:srgbClr val="E67E00"/>
+              <a:srgbClr val="808080"/>
             </a:solidFill>
             <a:prstDash val="dash"/>
           </a:ln>
@@ -7429,11 +7484,11 @@
             <a:avLst/>
           </a:prstGeom>
           <a:solidFill>
-            <a:srgbClr val="FFF3D6"/>
+            <a:srgbClr val="F5F5F5"/>
           </a:solidFill>
           <a:ln w="19050">
             <a:solidFill>
-              <a:srgbClr val="E67E00"/>
+              <a:srgbClr val="808080"/>
             </a:solidFill>
             <a:prstDash val="dash"/>
           </a:ln>
@@ -7494,11 +7549,11 @@
             <a:avLst/>
           </a:prstGeom>
           <a:solidFill>
-            <a:srgbClr val="FFF3D6"/>
+            <a:srgbClr val="F5F5F5"/>
           </a:solidFill>
           <a:ln w="19050">
             <a:solidFill>
-              <a:srgbClr val="E67E00"/>
+              <a:srgbClr val="808080"/>
             </a:solidFill>
             <a:prstDash val="dash"/>
           </a:ln>
@@ -7612,11 +7667,11 @@
             <a:avLst/>
           </a:prstGeom>
           <a:solidFill>
-            <a:srgbClr val="FFF3D6"/>
+            <a:srgbClr val="F5F5F5"/>
           </a:solidFill>
           <a:ln w="19050">
             <a:solidFill>
-              <a:srgbClr val="E67E00"/>
+              <a:srgbClr val="808080"/>
             </a:solidFill>
             <a:prstDash val="dash"/>
           </a:ln>
@@ -7700,6 +7755,14 @@
 <file path=ppt/slides/slide6.xml><?xml version="1.0" encoding="utf-8"?>
 <p:sld xmlns:a="http://schemas.openxmlformats.org/drawingml/2006/main" xmlns:p="http://schemas.openxmlformats.org/presentationml/2006/main" xmlns:r="http://schemas.openxmlformats.org/officeDocument/2006/relationships">
   <p:cSld>
+    <p:bg>
+      <p:bgPr>
+        <a:solidFill>
+          <a:srgbClr val="FFFFFF"/>
+        </a:solidFill>
+        <a:effectLst/>
+      </p:bgPr>
+    </p:bg>
     <p:spTree>
       <p:nvGrpSpPr>
         <p:cNvPr id="1" name=""/>
@@ -7901,7 +7964,7 @@
                       <a:r>
                         <a:rPr sz="1300" b="1">
                           <a:solidFill>
-                            <a:srgbClr val="FFFFFF"/>
+                            <a:srgbClr val="1B1B1B"/>
                           </a:solidFill>
                         </a:rPr>
                         <a:t>Test set</a:t>
@@ -7910,7 +7973,7 @@
                   </a:txBody>
                   <a:tcPr anchor="ctr">
                     <a:solidFill>
-                      <a:srgbClr val="1B5E20"/>
+                      <a:srgbClr val="E8F3E8"/>
                     </a:solidFill>
                   </a:tcPr>
                 </a:tc>
@@ -7923,7 +7986,7 @@
                       <a:r>
                         <a:rPr sz="1300" b="1">
                           <a:solidFill>
-                            <a:srgbClr val="FFFFFF"/>
+                            <a:srgbClr val="1B1B1B"/>
                           </a:solidFill>
                         </a:rPr>
                         <a:t>Photos</a:t>
@@ -7932,7 +7995,7 @@
                   </a:txBody>
                   <a:tcPr anchor="ctr">
                     <a:solidFill>
-                      <a:srgbClr val="1B5E20"/>
+                      <a:srgbClr val="E8F3E8"/>
                     </a:solidFill>
                   </a:tcPr>
                 </a:tc>
@@ -7945,7 +8008,7 @@
                       <a:r>
                         <a:rPr sz="1300" b="1">
                           <a:solidFill>
-                            <a:srgbClr val="FFFFFF"/>
+                            <a:srgbClr val="1B1B1B"/>
                           </a:solidFill>
                         </a:rPr>
                         <a:t>Classifier confident</a:t>
@@ -7954,7 +8017,7 @@
                   </a:txBody>
                   <a:tcPr anchor="ctr">
                     <a:solidFill>
-                      <a:srgbClr val="1B5E20"/>
+                      <a:srgbClr val="E8F3E8"/>
                     </a:solidFill>
                   </a:tcPr>
                 </a:tc>
@@ -7967,7 +8030,7 @@
                       <a:r>
                         <a:rPr sz="1300" b="1">
                           <a:solidFill>
-                            <a:srgbClr val="FFFFFF"/>
+                            <a:srgbClr val="1B1B1B"/>
                           </a:solidFill>
                         </a:rPr>
                         <a:t>Advice given</a:t>
@@ -7978,7 +8041,7 @@
                       <a:r>
                         <a:rPr sz="1300" b="1">
                           <a:solidFill>
-                            <a:srgbClr val="FFFFFF"/>
+                            <a:srgbClr val="1B1B1B"/>
                           </a:solidFill>
                         </a:rPr>
                         <a:t>(“no spray now”)</a:t>
@@ -7987,7 +8050,7 @@
                   </a:txBody>
                   <a:tcPr anchor="ctr">
                     <a:solidFill>
-                      <a:srgbClr val="1B5E20"/>
+                      <a:srgbClr val="E8F3E8"/>
                     </a:solidFill>
                   </a:tcPr>
                 </a:tc>
@@ -8000,7 +8063,7 @@
                       <a:r>
                         <a:rPr sz="1300" b="1">
                           <a:solidFill>
-                            <a:srgbClr val="FFFFFF"/>
+                            <a:srgbClr val="1B1B1B"/>
                           </a:solidFill>
                         </a:rPr>
                         <a:t>BLB question asked</a:t>
@@ -8009,7 +8072,7 @@
                   </a:txBody>
                   <a:tcPr anchor="ctr">
                     <a:solidFill>
-                      <a:srgbClr val="1B5E20"/>
+                      <a:srgbClr val="E8F3E8"/>
                     </a:solidFill>
                   </a:tcPr>
                 </a:tc>
@@ -8022,7 +8085,7 @@
                       <a:r>
                         <a:rPr sz="1300" b="1">
                           <a:solidFill>
-                            <a:srgbClr val="FFFFFF"/>
+                            <a:srgbClr val="1B1B1B"/>
                           </a:solidFill>
                         </a:rPr>
                         <a:t>Blast question asked</a:t>
@@ -8031,7 +8094,7 @@
                   </a:txBody>
                   <a:tcPr anchor="ctr">
                     <a:solidFill>
-                      <a:srgbClr val="1B5E20"/>
+                      <a:srgbClr val="E8F3E8"/>
                     </a:solidFill>
                   </a:tcPr>
                 </a:tc>
@@ -8044,7 +8107,7 @@
                       <a:r>
                         <a:rPr sz="1300" b="1">
                           <a:solidFill>
-                            <a:srgbClr val="FFFFFF"/>
+                            <a:srgbClr val="1B1B1B"/>
                           </a:solidFill>
                         </a:rPr>
                         <a:t>Wrong spray advice</a:t>
@@ -8053,7 +8116,7 @@
                   </a:txBody>
                   <a:tcPr anchor="ctr">
                     <a:solidFill>
-                      <a:srgbClr val="1B5E20"/>
+                      <a:srgbClr val="E8F3E8"/>
                     </a:solidFill>
                   </a:tcPr>
                 </a:tc>
@@ -8738,6 +8801,14 @@
 <file path=ppt/slides/slide7.xml><?xml version="1.0" encoding="utf-8"?>
 <p:sld xmlns:a="http://schemas.openxmlformats.org/drawingml/2006/main" xmlns:p="http://schemas.openxmlformats.org/presentationml/2006/main" xmlns:r="http://schemas.openxmlformats.org/officeDocument/2006/relationships">
   <p:cSld>
+    <p:bg>
+      <p:bgPr>
+        <a:solidFill>
+          <a:srgbClr val="FFFFFF"/>
+        </a:solidFill>
+        <a:effectLst/>
+      </p:bgPr>
+    </p:bg>
     <p:spTree>
       <p:nvGrpSpPr>
         <p:cNvPr id="1" name=""/>
@@ -9041,6 +9112,14 @@
 <file path=ppt/slides/slide8.xml><?xml version="1.0" encoding="utf-8"?>
 <p:sld xmlns:a="http://schemas.openxmlformats.org/drawingml/2006/main" xmlns:p="http://schemas.openxmlformats.org/presentationml/2006/main" xmlns:r="http://schemas.openxmlformats.org/officeDocument/2006/relationships">
   <p:cSld>
+    <p:bg>
+      <p:bgPr>
+        <a:solidFill>
+          <a:srgbClr val="FFFFFF"/>
+        </a:solidFill>
+        <a:effectLst/>
+      </p:bgPr>
+    </p:bg>
     <p:spTree>
       <p:nvGrpSpPr>
         <p:cNvPr id="1" name=""/>
@@ -9654,6 +9733,36 @@
                 </a:solidFill>
               </a:rPr>
               <a:t>https://huggingface.co/Raiyan465/kom-bish-rice-leaf</a:t>
+            </a:r>
+          </a:p>
+          <a:p>
+            <a:pPr>
+              <a:spcAft>
+                <a:spcPts val="200"/>
+              </a:spcAft>
+            </a:pPr>
+            <a:r>
+              <a:rPr sz="1200" b="0">
+                <a:solidFill>
+                  <a:srgbClr val="1B1B1B"/>
+                </a:solidFill>
+              </a:rPr>
+              <a:t>Video</a:t>
+            </a:r>
+          </a:p>
+          <a:p>
+            <a:pPr>
+              <a:spcAft>
+                <a:spcPts val="200"/>
+              </a:spcAft>
+            </a:pPr>
+            <a:r>
+              <a:rPr sz="1200" b="0">
+                <a:solidFill>
+                  <a:srgbClr val="1B1B1B"/>
+                </a:solidFill>
+              </a:rPr>
+              <a:t>https://youtu.be/UUdfN2WERf4</a:t>
             </a:r>
           </a:p>
         </p:txBody>

</xml_diff>